<commit_message>
nsi: the RIO lockup as vector art, from RIO's own overview PDF
The Research & Innovation Office lockup (nsi's sign-off and its white version on the band
title) was the deck's 1911x298 PNG. RIO's two-page overview
(colorado.edu/researchinnovation/.../rio_overview_071620.pdf, laid out in InDesign) carries
the lockup in its footer as vector art: cut out with pdftocairo -svg (the lettering as
glyph outlines, the monogram four paths), boxed tightly (213.69 x 33.83 pt, aspect 6.317),
the PDF's print gold #CCB567 set to CU Gold #CFB87C and the dark to #231F20. The white
version fills the lettering white and leaves the monogram as it is. Each SVG is kept with
a PNG (rsvg-convert -h 240) for HTML and pptx and a PDF of the same name, which LaTeX
picks, so the PDF deck's RIO lockups are vector (no raster copy left in the built PDF).

Co-Authored-By: Claude Opus 5.5 <noreply@anthropic.com>
Claude-Session: https://claude.ai/code/session_01QxTZPtUJESWqMyXE15JCRv
</commit_message>
<xml_diff>
--- a/docs/common/liveries/nsi/template.pptx
+++ b/docs/common/liveries/nsi/template.pptx
@@ -128,7 +128,7 @@
         <p:spPr>
           <a:xfrm>
             <a:off x="731520" y="5534406"/>
-            <a:ext cx="4837839" cy="754380"/>
+            <a:ext cx="4765418" cy="754380"/>
           </a:xfrm>
           <a:prstGeom prst="rect">
             <a:avLst/>
@@ -676,7 +676,7 @@
         <p:spPr>
           <a:xfrm>
             <a:off x="731520" y="6309360"/>
-            <a:ext cx="2199018" cy="342900"/>
+            <a:ext cx="2166099" cy="342900"/>
           </a:xfrm>
           <a:prstGeom prst="rect">
             <a:avLst/>
@@ -1858,7 +1858,7 @@
         <p:spPr>
           <a:xfrm>
             <a:off x="731520" y="5534406"/>
-            <a:ext cx="4837839" cy="754380"/>
+            <a:ext cx="4765418" cy="754380"/>
           </a:xfrm>
           <a:prstGeom prst="rect">
             <a:avLst/>
@@ -2194,7 +2194,7 @@
         <p:spPr>
           <a:xfrm>
             <a:off x="731520" y="6309360"/>
-            <a:ext cx="2199018" cy="342900"/>
+            <a:ext cx="2166099" cy="342900"/>
           </a:xfrm>
           <a:prstGeom prst="rect">
             <a:avLst/>
@@ -2768,7 +2768,7 @@
         <p:spPr>
           <a:xfrm>
             <a:off x="731520" y="6309360"/>
-            <a:ext cx="2199018" cy="342900"/>
+            <a:ext cx="2166099" cy="342900"/>
           </a:xfrm>
           <a:prstGeom prst="rect">
             <a:avLst/>

</xml_diff>

<commit_message>
nsi: the RIO lockup as vector art, from RIO's own overview PDF (#22)
The Research & Innovation Office lockup (nsi's sign-off and its white version on the band
title) was the deck's 1911x298 PNG. RIO's two-page overview
(colorado.edu/researchinnovation/.../rio_overview_071620.pdf, laid out in InDesign) carries
the lockup in its footer as vector art: cut out with pdftocairo -svg (the lettering as
glyph outlines, the monogram four paths), boxed tightly (213.69 x 33.83 pt, aspect 6.317),
the PDF's print gold #CCB567 set to CU Gold #CFB87C and the dark to #231F20. The white
version fills the lettering white and leaves the monogram as it is. Each SVG is kept with
a PNG (rsvg-convert -h 240) for HTML and pptx and a PDF of the same name, which LaTeX
picks, so the PDF deck's RIO lockups are vector (no raster copy left in the built PDF).


Claude-Session: https://claude.ai/code/session_01QxTZPtUJESWqMyXE15JCRv

Co-authored-by: Claude Opus 5.5 <noreply@anthropic.com>
</commit_message>
<xml_diff>
--- a/docs/common/liveries/nsi/template.pptx
+++ b/docs/common/liveries/nsi/template.pptx
@@ -128,7 +128,7 @@
         <p:spPr>
           <a:xfrm>
             <a:off x="731520" y="5534406"/>
-            <a:ext cx="4837839" cy="754380"/>
+            <a:ext cx="4765418" cy="754380"/>
           </a:xfrm>
           <a:prstGeom prst="rect">
             <a:avLst/>
@@ -676,7 +676,7 @@
         <p:spPr>
           <a:xfrm>
             <a:off x="731520" y="6309360"/>
-            <a:ext cx="2199018" cy="342900"/>
+            <a:ext cx="2166099" cy="342900"/>
           </a:xfrm>
           <a:prstGeom prst="rect">
             <a:avLst/>
@@ -1858,7 +1858,7 @@
         <p:spPr>
           <a:xfrm>
             <a:off x="731520" y="5534406"/>
-            <a:ext cx="4837839" cy="754380"/>
+            <a:ext cx="4765418" cy="754380"/>
           </a:xfrm>
           <a:prstGeom prst="rect">
             <a:avLst/>
@@ -2194,7 +2194,7 @@
         <p:spPr>
           <a:xfrm>
             <a:off x="731520" y="6309360"/>
-            <a:ext cx="2199018" cy="342900"/>
+            <a:ext cx="2166099" cy="342900"/>
           </a:xfrm>
           <a:prstGeom prst="rect">
             <a:avLst/>
@@ -2768,7 +2768,7 @@
         <p:spPr>
           <a:xfrm>
             <a:off x="731520" y="6309360"/>
-            <a:ext cx="2199018" cy="342900"/>
+            <a:ext cx="2166099" cy="342900"/>
           </a:xfrm>
           <a:prstGeom prst="rect">
             <a:avLst/>

</xml_diff>